<commit_message>
feat: add PPTX to PDF converter
- Add internal/pptx2pdf package with PDF rendering via go-pdf/fpdf
- Support text, images, and tables with borders and header styling
- Handle page overflow and slide numbering
- Enhance pptx2md parser: tables (graphicFrame), field text (a:fld),
  connector shapes (cxnSp), grouped shape extraction
- Add menu option 3 in interactive UI
- Update testdata with 3-slide sample including table
- All 13 tests passing, 17/17 content checks verified in PDF output

Co-authored-by: Copilot <223556219+Copilot@users.noreply.github.com>
</commit_message>
<xml_diff>
--- a/testdata/sample.pptx
+++ b/testdata/sample.pptx
@@ -2,11 +2,12 @@
 <file path=ppt/presentation.xml><?xml version="1.0" encoding="utf-8"?>
 <p:presentation xmlns:a="http://schemas.openxmlformats.org/drawingml/2006/main" xmlns:p="http://schemas.openxmlformats.org/presentationml/2006/main" xmlns:r="http://schemas.openxmlformats.org/officeDocument/2006/relationships">
   <p:sldMasterIdLst>
-    <p:sldMasterId r:id="rId3"/>
+    <p:sldMasterId r:id="rId4"/>
   </p:sldMasterIdLst>
   <p:sldIdLst>
     <p:sldId id="256" r:id="rId1"/>
     <p:sldId id="257" r:id="rId2"/>
+    <p:sldId id="258" r:id="rId3"/>
   </p:sldIdLst>
 </p:presentation>
 </file>
@@ -182,4 +183,217 @@
     </p:spTree>
   </p:cSld>
 </p:sld>
+</file>
+
+<file path=ppt/slides/slide3.xml><?xml version="1.0" encoding="utf-8"?>
+<p:sld xmlns:a="http://schemas.openxmlformats.org/drawingml/2006/main" xmlns:p="http://schemas.openxmlformats.org/presentationml/2006/main" xmlns:r="http://schemas.openxmlformats.org/officeDocument/2006/relationships">
+  <p:cSld>
+    <p:spTree>
+      <p:nvGrpSpPr>
+        <p:cNvPr id="1" name=""/>
+        <p:cNvGrpSpPr/>
+        <p:nvPr/>
+      </p:nvGrpSpPr>
+      <p:grpSpPr/>
+      <p:sp>
+        <p:nvSpPr>
+          <p:cNvPr id="2" name="Title 1"/>
+          <p:cNvSpPr>
+            <a:spLocks noGrp="1"/>
+          </p:cNvSpPr>
+          <p:nvPr>
+            <p:ph type="title"/>
+          </p:nvPr>
+        </p:nvSpPr>
+        <p:spPr/>
+        <p:txBody>
+          <a:bodyPr/>
+          <a:lstStyle/>
+          <a:p>
+            <a:r>
+              <a:rPr lang="en-US"/>
+              <a:t>Comparison Table</a:t>
+            </a:r>
+          </a:p>
+        </p:txBody>
+      </p:sp>
+      <p:graphicFrame>
+        <p:nvGraphicFramePr>
+          <p:cNvPr id="5" name="Table 4"/>
+          <p:cNvGraphicFramePr>
+            <a:graphicFrameLocks noGrp="1"/>
+          </p:cNvGraphicFramePr>
+          <p:nvPr/>
+        </p:nvGraphicFramePr>
+        <p:xfrm>
+          <a:off x="0" y="0"/>
+          <a:ext cx="9144000" cy="3600000"/>
+        </p:xfrm>
+        <a:graphic>
+          <a:graphicData uri="http://schemas.openxmlformats.org/drawingml/2006/table">
+            <a:tbl>
+              <a:tblGrid>
+                <a:gridCol w="3048000"/>
+                <a:gridCol w="3048000"/>
+                <a:gridCol w="3048000"/>
+              </a:tblGrid>
+              <a:tr h="370840">
+                <a:tc>
+                  <a:txBody>
+                    <a:bodyPr/>
+                    <a:lstStyle/>
+                    <a:p>
+                      <a:r>
+                        <a:rPr lang="en-US"/>
+                        <a:t>Feature</a:t>
+                      </a:r>
+                    </a:p>
+                  </a:txBody>
+                </a:tc>
+                <a:tc>
+                  <a:txBody>
+                    <a:bodyPr/>
+                    <a:lstStyle/>
+                    <a:p>
+                      <a:r>
+                        <a:rPr lang="en-US"/>
+                        <a:t>Status</a:t>
+                      </a:r>
+                    </a:p>
+                  </a:txBody>
+                </a:tc>
+                <a:tc>
+                  <a:txBody>
+                    <a:bodyPr/>
+                    <a:lstStyle/>
+                    <a:p>
+                      <a:r>
+                        <a:rPr lang="en-US"/>
+                        <a:t>Notes</a:t>
+                      </a:r>
+                    </a:p>
+                  </a:txBody>
+                </a:tc>
+              </a:tr>
+              <a:tr h="370840">
+                <a:tc>
+                  <a:txBody>
+                    <a:bodyPr/>
+                    <a:lstStyle/>
+                    <a:p>
+                      <a:r>
+                        <a:rPr lang="en-US"/>
+                        <a:t>XLSX to MD</a:t>
+                      </a:r>
+                    </a:p>
+                  </a:txBody>
+                </a:tc>
+                <a:tc>
+                  <a:txBody>
+                    <a:bodyPr/>
+                    <a:lstStyle/>
+                    <a:p>
+                      <a:r>
+                        <a:rPr lang="en-US"/>
+                        <a:t>Done</a:t>
+                      </a:r>
+                    </a:p>
+                  </a:txBody>
+                </a:tc>
+                <a:tc>
+                  <a:txBody>
+                    <a:bodyPr/>
+                    <a:lstStyle/>
+                    <a:p>
+                      <a:r>
+                        <a:rPr lang="en-US"/>
+                        <a:t>Multi-sheet support</a:t>
+                      </a:r>
+                    </a:p>
+                  </a:txBody>
+                </a:tc>
+              </a:tr>
+              <a:tr h="370840">
+                <a:tc>
+                  <a:txBody>
+                    <a:bodyPr/>
+                    <a:lstStyle/>
+                    <a:p>
+                      <a:r>
+                        <a:rPr lang="en-US"/>
+                        <a:t>PPTX to MD</a:t>
+                      </a:r>
+                    </a:p>
+                  </a:txBody>
+                </a:tc>
+                <a:tc>
+                  <a:txBody>
+                    <a:bodyPr/>
+                    <a:lstStyle/>
+                    <a:p>
+                      <a:r>
+                        <a:rPr lang="en-US"/>
+                        <a:t>Done</a:t>
+                      </a:r>
+                    </a:p>
+                  </a:txBody>
+                </a:tc>
+                <a:tc>
+                  <a:txBody>
+                    <a:bodyPr/>
+                    <a:lstStyle/>
+                    <a:p>
+                      <a:r>
+                        <a:rPr lang="en-US"/>
+                        <a:t>Image extraction</a:t>
+                      </a:r>
+                    </a:p>
+                  </a:txBody>
+                </a:tc>
+              </a:tr>
+              <a:tr h="370840">
+                <a:tc>
+                  <a:txBody>
+                    <a:bodyPr/>
+                    <a:lstStyle/>
+                    <a:p>
+                      <a:r>
+                        <a:rPr lang="en-US"/>
+                        <a:t>PPTX to PDF</a:t>
+                      </a:r>
+                    </a:p>
+                  </a:txBody>
+                </a:tc>
+                <a:tc>
+                  <a:txBody>
+                    <a:bodyPr/>
+                    <a:lstStyle/>
+                    <a:p>
+                      <a:r>
+                        <a:rPr lang="en-US"/>
+                        <a:t>In Progress</a:t>
+                      </a:r>
+                    </a:p>
+                  </a:txBody>
+                </a:tc>
+                <a:tc>
+                  <a:txBody>
+                    <a:bodyPr/>
+                    <a:lstStyle/>
+                    <a:p>
+                      <a:r>
+                        <a:rPr lang="en-US"/>
+                        <a:t>Tables and images</a:t>
+                      </a:r>
+                    </a:p>
+                  </a:txBody>
+                </a:tc>
+              </a:tr>
+            </a:tbl>
+          </a:graphicData>
+        </a:graphic>
+      </p:graphicFrame>
+    </p:spTree>
+  </p:cSld>
+</p:sld>
 </file>
</xml_diff>